<commit_message>
render: W91 (auto-published from production-dispatcher)
</commit_message>
<xml_diff>
--- a/W91-ed574e/mon/slides/06-closing.pptx
+++ b/W91-ed574e/mon/slides/06-closing.pptx
@@ -3148,6 +3148,45 @@
         <p:spPr>
           <a:xfrm>
             <a:off x="762000" y="8191500"/>
+            <a:ext cx="8763000" cy="1524000"/>
+          </a:xfrm>
+          <a:prstGeom prst="rect">
+            <a:avLst/>
+          </a:prstGeom>
+          <a:noFill/>
+        </p:spPr>
+        <p:txBody>
+          <a:bodyPr wrap="square" lIns="0" rIns="0" tIns="0" bIns="0">
+            <a:spAutoFit/>
+          </a:bodyPr>
+          <a:lstStyle/>
+          <a:p>
+            <a:pPr>
+              <a:lnSpc>
+                <a:spcPct val="135000"/>
+              </a:lnSpc>
+            </a:pPr>
+            <a:r>
+              <a:rPr sz="2200" b="0" i="1">
+                <a:solidFill>
+                  <a:srgbClr val="F5F1EC"/>
+                </a:solidFill>
+                <a:latin typeface="Playfair Display"/>
+              </a:rPr>
+              <a:t>Save this if you're watching this market from the sidelines.</a:t>
+            </a:r>
+          </a:p>
+        </p:txBody>
+      </p:sp>
+      <p:sp>
+        <p:nvSpPr>
+          <p:cNvPr id="4" name="TextBox 3"/>
+          <p:cNvSpPr txBox="1"/>
+          <p:nvPr/>
+        </p:nvSpPr>
+        <p:spPr>
+          <a:xfrm>
+            <a:off x="762000" y="9906000"/>
             <a:ext cx="8763000" cy="1143000"/>
           </a:xfrm>
           <a:prstGeom prst="rect">
@@ -3169,45 +3208,6 @@
                 <a:latin typeface="Pinyon Script"/>
               </a:rPr>
               <a:t>— Laurène</a:t>
-            </a:r>
-          </a:p>
-        </p:txBody>
-      </p:sp>
-      <p:sp>
-        <p:nvSpPr>
-          <p:cNvPr id="4" name="TextBox 3"/>
-          <p:cNvSpPr txBox="1"/>
-          <p:nvPr/>
-        </p:nvSpPr>
-        <p:spPr>
-          <a:xfrm>
-            <a:off x="762000" y="9525000"/>
-            <a:ext cx="8763000" cy="1524000"/>
-          </a:xfrm>
-          <a:prstGeom prst="rect">
-            <a:avLst/>
-          </a:prstGeom>
-          <a:noFill/>
-        </p:spPr>
-        <p:txBody>
-          <a:bodyPr wrap="square" lIns="0" rIns="0" tIns="0" bIns="0">
-            <a:spAutoFit/>
-          </a:bodyPr>
-          <a:lstStyle/>
-          <a:p>
-            <a:pPr>
-              <a:lnSpc>
-                <a:spcPct val="135000"/>
-              </a:lnSpc>
-            </a:pPr>
-            <a:r>
-              <a:rPr sz="2200" b="0" i="1">
-                <a:solidFill>
-                  <a:srgbClr val="F5F1EC"/>
-                </a:solidFill>
-                <a:latin typeface="Playfair Display"/>
-              </a:rPr>
-              <a:t>Save this if you're watching this market from the sidelines.</a:t>
             </a:r>
           </a:p>
         </p:txBody>

</xml_diff>